<commit_message>
Fixes ezrsurvey Split ai features ezrintelligence
</commit_message>
<xml_diff>
--- a/ezr-survey/inst/templates/ezrsurvey-16x9-plain.pptx
+++ b/ezr-survey/inst/templates/ezrsurvey-16x9-plain.pptx
@@ -141,8 +141,14 @@
           </a:xfrm>
         </p:spPr>
         <p:txBody>
-          <a:bodyPr/>
-          <a:lstStyle/>
+          <a:bodyPr>
+            <a:normAutofit xmlns:a="http://schemas.openxmlformats.org/drawingml/2006/main"/>
+          </a:bodyPr>
+          <a:lstStyle>
+            <a:lvl1pPr xmlns:a="http://schemas.openxmlformats.org/drawingml/2006/main" algn="l">
+              <a:defRPr xmlns:a="http://schemas.openxmlformats.org/drawingml/2006/main" sz="4000" b="1"/>
+            </a:lvl1pPr>
+          </a:lstStyle>
           <a:p>
             <a:r>
               <a:rPr lang="en-US" smtClean="0"/>
@@ -169,11 +175,13 @@
           </a:xfrm>
         </p:spPr>
         <p:txBody>
-          <a:bodyPr/>
+          <a:bodyPr>
+            <a:normAutofit xmlns:a="http://schemas.openxmlformats.org/drawingml/2006/main"/>
+          </a:bodyPr>
           <a:lstStyle>
-            <a:lvl1pPr marL="0" indent="0" algn="ctr">
-              <a:buNone/>
-              <a:defRPr>
+            <a:lvl1pPr marL="0" indent="0" algn="l">
+              <a:buNone/>
+              <a:defRPr sz="1800">
                 <a:solidFill>
                   <a:schemeClr val="tx1">
                     <a:tint val="75000"/>
@@ -283,7 +291,9 @@
         </p:nvSpPr>
         <p:spPr/>
         <p:txBody>
-          <a:bodyPr/>
+          <a:bodyPr>
+            <a:normAutofit xmlns:a="http://schemas.openxmlformats.org/drawingml/2006/main"/>
+          </a:bodyPr>
           <a:lstStyle/>
           <a:p>
             <a:fld id="{E6744CE3-0875-4B69-89C0-6F72D8139561}" type="datetimeFigureOut">
@@ -306,7 +316,9 @@
         </p:nvSpPr>
         <p:spPr/>
         <p:txBody>
-          <a:bodyPr/>
+          <a:bodyPr>
+            <a:normAutofit xmlns:a="http://schemas.openxmlformats.org/drawingml/2006/main"/>
+          </a:bodyPr>
           <a:lstStyle/>
           <a:p>
             <a:endParaRPr lang="en-GB"/>
@@ -325,7 +337,9 @@
         </p:nvSpPr>
         <p:spPr/>
         <p:txBody>
-          <a:bodyPr/>
+          <a:bodyPr>
+            <a:normAutofit xmlns:a="http://schemas.openxmlformats.org/drawingml/2006/main"/>
+          </a:bodyPr>
           <a:lstStyle/>
           <a:p>
             <a:fld id="{8DADB20D-508E-4C6D-A9E4-257D5607B0F6}" type="slidenum">
@@ -378,7 +392,9 @@
         </p:nvSpPr>
         <p:spPr/>
         <p:txBody>
-          <a:bodyPr/>
+          <a:bodyPr>
+            <a:normAutofit xmlns:a="http://schemas.openxmlformats.org/drawingml/2006/main"/>
+          </a:bodyPr>
           <a:lstStyle/>
           <a:p>
             <a:r>
@@ -401,7 +417,9 @@
         </p:nvSpPr>
         <p:spPr/>
         <p:txBody>
-          <a:bodyPr/>
+          <a:bodyPr>
+            <a:normAutofit xmlns:a="http://schemas.openxmlformats.org/drawingml/2006/main"/>
+          </a:bodyPr>
           <a:lstStyle/>
           <a:p>
             <a:pPr lvl="0"/>
@@ -453,7 +471,9 @@
         </p:nvSpPr>
         <p:spPr/>
         <p:txBody>
-          <a:bodyPr/>
+          <a:bodyPr>
+            <a:normAutofit xmlns:a="http://schemas.openxmlformats.org/drawingml/2006/main"/>
+          </a:bodyPr>
           <a:lstStyle/>
           <a:p>
             <a:fld id="{E6744CE3-0875-4B69-89C0-6F72D8139561}" type="datetimeFigureOut">
@@ -476,7 +496,9 @@
         </p:nvSpPr>
         <p:spPr/>
         <p:txBody>
-          <a:bodyPr/>
+          <a:bodyPr>
+            <a:normAutofit xmlns:a="http://schemas.openxmlformats.org/drawingml/2006/main"/>
+          </a:bodyPr>
           <a:lstStyle/>
           <a:p>
             <a:endParaRPr lang="en-GB"/>
@@ -495,7 +517,9 @@
         </p:nvSpPr>
         <p:spPr/>
         <p:txBody>
-          <a:bodyPr/>
+          <a:bodyPr>
+            <a:normAutofit xmlns:a="http://schemas.openxmlformats.org/drawingml/2006/main"/>
+          </a:bodyPr>
           <a:lstStyle/>
           <a:p>
             <a:fld id="{8DADB20D-508E-4C6D-A9E4-257D5607B0F6}" type="slidenum">
@@ -553,7 +577,9 @@
           </a:xfrm>
         </p:spPr>
         <p:txBody>
-          <a:bodyPr anchor="t"/>
+          <a:bodyPr anchor="t">
+            <a:normAutofit xmlns:a="http://schemas.openxmlformats.org/drawingml/2006/main"/>
+          </a:bodyPr>
           <a:lstStyle>
             <a:lvl1pPr algn="l">
               <a:defRPr sz="4000" b="1" cap="all"/>
@@ -585,7 +611,9 @@
           </a:xfrm>
         </p:spPr>
         <p:txBody>
-          <a:bodyPr anchor="b"/>
+          <a:bodyPr anchor="b">
+            <a:normAutofit xmlns:a="http://schemas.openxmlformats.org/drawingml/2006/main"/>
+          </a:bodyPr>
           <a:lstStyle>
             <a:lvl1pPr marL="0" indent="0">
               <a:buNone/>
@@ -699,7 +727,9 @@
         </p:nvSpPr>
         <p:spPr/>
         <p:txBody>
-          <a:bodyPr/>
+          <a:bodyPr>
+            <a:normAutofit xmlns:a="http://schemas.openxmlformats.org/drawingml/2006/main"/>
+          </a:bodyPr>
           <a:lstStyle/>
           <a:p>
             <a:fld id="{E6744CE3-0875-4B69-89C0-6F72D8139561}" type="datetimeFigureOut">
@@ -722,7 +752,9 @@
         </p:nvSpPr>
         <p:spPr/>
         <p:txBody>
-          <a:bodyPr/>
+          <a:bodyPr>
+            <a:normAutofit xmlns:a="http://schemas.openxmlformats.org/drawingml/2006/main"/>
+          </a:bodyPr>
           <a:lstStyle/>
           <a:p>
             <a:endParaRPr lang="en-GB"/>
@@ -741,7 +773,9 @@
         </p:nvSpPr>
         <p:spPr/>
         <p:txBody>
-          <a:bodyPr/>
+          <a:bodyPr>
+            <a:normAutofit xmlns:a="http://schemas.openxmlformats.org/drawingml/2006/main"/>
+          </a:bodyPr>
           <a:lstStyle/>
           <a:p>
             <a:fld id="{8DADB20D-508E-4C6D-A9E4-257D5607B0F6}" type="slidenum">
@@ -794,7 +828,9 @@
         </p:nvSpPr>
         <p:spPr/>
         <p:txBody>
-          <a:bodyPr/>
+          <a:bodyPr>
+            <a:normAutofit xmlns:a="http://schemas.openxmlformats.org/drawingml/2006/main"/>
+          </a:bodyPr>
           <a:lstStyle/>
           <a:p>
             <a:r>
@@ -822,7 +858,9 @@
           </a:xfrm>
         </p:spPr>
         <p:txBody>
-          <a:bodyPr/>
+          <a:bodyPr>
+            <a:normAutofit xmlns:a="http://schemas.openxmlformats.org/drawingml/2006/main"/>
+          </a:bodyPr>
           <a:lstStyle>
             <a:lvl1pPr>
               <a:defRPr sz="2800"/>
@@ -907,7 +945,9 @@
           </a:xfrm>
         </p:spPr>
         <p:txBody>
-          <a:bodyPr/>
+          <a:bodyPr>
+            <a:normAutofit xmlns:a="http://schemas.openxmlformats.org/drawingml/2006/main"/>
+          </a:bodyPr>
           <a:lstStyle>
             <a:lvl1pPr>
               <a:defRPr sz="2800"/>
@@ -987,7 +1027,9 @@
         </p:nvSpPr>
         <p:spPr/>
         <p:txBody>
-          <a:bodyPr/>
+          <a:bodyPr>
+            <a:normAutofit xmlns:a="http://schemas.openxmlformats.org/drawingml/2006/main"/>
+          </a:bodyPr>
           <a:lstStyle/>
           <a:p>
             <a:fld id="{E6744CE3-0875-4B69-89C0-6F72D8139561}" type="datetimeFigureOut">
@@ -1010,7 +1052,9 @@
         </p:nvSpPr>
         <p:spPr/>
         <p:txBody>
-          <a:bodyPr/>
+          <a:bodyPr>
+            <a:normAutofit xmlns:a="http://schemas.openxmlformats.org/drawingml/2006/main"/>
+          </a:bodyPr>
           <a:lstStyle/>
           <a:p>
             <a:endParaRPr lang="en-GB"/>
@@ -1029,7 +1073,9 @@
         </p:nvSpPr>
         <p:spPr/>
         <p:txBody>
-          <a:bodyPr/>
+          <a:bodyPr>
+            <a:normAutofit xmlns:a="http://schemas.openxmlformats.org/drawingml/2006/main"/>
+          </a:bodyPr>
           <a:lstStyle/>
           <a:p>
             <a:fld id="{8DADB20D-508E-4C6D-A9E4-257D5607B0F6}" type="slidenum">
@@ -1082,7 +1128,9 @@
         </p:nvSpPr>
         <p:spPr/>
         <p:txBody>
-          <a:bodyPr/>
+          <a:bodyPr>
+            <a:normAutofit xmlns:a="http://schemas.openxmlformats.org/drawingml/2006/main"/>
+          </a:bodyPr>
           <a:lstStyle>
             <a:lvl1pPr>
               <a:defRPr/>
@@ -1114,7 +1162,9 @@
           </a:xfrm>
         </p:spPr>
         <p:txBody>
-          <a:bodyPr anchor="b"/>
+          <a:bodyPr anchor="b">
+            <a:normAutofit xmlns:a="http://schemas.openxmlformats.org/drawingml/2006/main"/>
+          </a:bodyPr>
           <a:lstStyle>
             <a:lvl1pPr marL="0" indent="0">
               <a:buNone/>
@@ -1179,7 +1229,9 @@
           </a:xfrm>
         </p:spPr>
         <p:txBody>
-          <a:bodyPr/>
+          <a:bodyPr>
+            <a:normAutofit xmlns:a="http://schemas.openxmlformats.org/drawingml/2006/main"/>
+          </a:bodyPr>
           <a:lstStyle>
             <a:lvl1pPr>
               <a:defRPr sz="2400"/>
@@ -1264,7 +1316,9 @@
           </a:xfrm>
         </p:spPr>
         <p:txBody>
-          <a:bodyPr anchor="b"/>
+          <a:bodyPr anchor="b">
+            <a:normAutofit xmlns:a="http://schemas.openxmlformats.org/drawingml/2006/main"/>
+          </a:bodyPr>
           <a:lstStyle>
             <a:lvl1pPr marL="0" indent="0">
               <a:buNone/>
@@ -1329,7 +1383,9 @@
           </a:xfrm>
         </p:spPr>
         <p:txBody>
-          <a:bodyPr/>
+          <a:bodyPr>
+            <a:normAutofit xmlns:a="http://schemas.openxmlformats.org/drawingml/2006/main"/>
+          </a:bodyPr>
           <a:lstStyle>
             <a:lvl1pPr>
               <a:defRPr sz="2400"/>
@@ -1409,7 +1465,9 @@
         </p:nvSpPr>
         <p:spPr/>
         <p:txBody>
-          <a:bodyPr/>
+          <a:bodyPr>
+            <a:normAutofit xmlns:a="http://schemas.openxmlformats.org/drawingml/2006/main"/>
+          </a:bodyPr>
           <a:lstStyle/>
           <a:p>
             <a:fld id="{E6744CE3-0875-4B69-89C0-6F72D8139561}" type="datetimeFigureOut">
@@ -1432,7 +1490,9 @@
         </p:nvSpPr>
         <p:spPr/>
         <p:txBody>
-          <a:bodyPr/>
+          <a:bodyPr>
+            <a:normAutofit xmlns:a="http://schemas.openxmlformats.org/drawingml/2006/main"/>
+          </a:bodyPr>
           <a:lstStyle/>
           <a:p>
             <a:endParaRPr lang="en-GB"/>
@@ -1451,7 +1511,9 @@
         </p:nvSpPr>
         <p:spPr/>
         <p:txBody>
-          <a:bodyPr/>
+          <a:bodyPr>
+            <a:normAutofit xmlns:a="http://schemas.openxmlformats.org/drawingml/2006/main"/>
+          </a:bodyPr>
           <a:lstStyle/>
           <a:p>
             <a:fld id="{8DADB20D-508E-4C6D-A9E4-257D5607B0F6}" type="slidenum">
@@ -1504,7 +1566,9 @@
         </p:nvSpPr>
         <p:spPr/>
         <p:txBody>
-          <a:bodyPr/>
+          <a:bodyPr>
+            <a:normAutofit xmlns:a="http://schemas.openxmlformats.org/drawingml/2006/main"/>
+          </a:bodyPr>
           <a:lstStyle/>
           <a:p>
             <a:r>
@@ -1527,7 +1591,9 @@
         </p:nvSpPr>
         <p:spPr/>
         <p:txBody>
-          <a:bodyPr/>
+          <a:bodyPr>
+            <a:normAutofit xmlns:a="http://schemas.openxmlformats.org/drawingml/2006/main"/>
+          </a:bodyPr>
           <a:lstStyle/>
           <a:p>
             <a:fld id="{E6744CE3-0875-4B69-89C0-6F72D8139561}" type="datetimeFigureOut">
@@ -1550,7 +1616,9 @@
         </p:nvSpPr>
         <p:spPr/>
         <p:txBody>
-          <a:bodyPr/>
+          <a:bodyPr>
+            <a:normAutofit xmlns:a="http://schemas.openxmlformats.org/drawingml/2006/main"/>
+          </a:bodyPr>
           <a:lstStyle/>
           <a:p>
             <a:endParaRPr lang="en-GB"/>
@@ -1569,7 +1637,9 @@
         </p:nvSpPr>
         <p:spPr/>
         <p:txBody>
-          <a:bodyPr/>
+          <a:bodyPr>
+            <a:normAutofit xmlns:a="http://schemas.openxmlformats.org/drawingml/2006/main"/>
+          </a:bodyPr>
           <a:lstStyle/>
           <a:p>
             <a:fld id="{8DADB20D-508E-4C6D-A9E4-257D5607B0F6}" type="slidenum">
@@ -1622,7 +1692,9 @@
         </p:nvSpPr>
         <p:spPr/>
         <p:txBody>
-          <a:bodyPr/>
+          <a:bodyPr>
+            <a:normAutofit xmlns:a="http://schemas.openxmlformats.org/drawingml/2006/main"/>
+          </a:bodyPr>
           <a:lstStyle/>
           <a:p>
             <a:fld id="{E6744CE3-0875-4B69-89C0-6F72D8139561}" type="datetimeFigureOut">
@@ -1645,7 +1717,9 @@
         </p:nvSpPr>
         <p:spPr/>
         <p:txBody>
-          <a:bodyPr/>
+          <a:bodyPr>
+            <a:normAutofit xmlns:a="http://schemas.openxmlformats.org/drawingml/2006/main"/>
+          </a:bodyPr>
           <a:lstStyle/>
           <a:p>
             <a:endParaRPr lang="en-GB"/>
@@ -1664,7 +1738,9 @@
         </p:nvSpPr>
         <p:spPr/>
         <p:txBody>
-          <a:bodyPr/>
+          <a:bodyPr>
+            <a:normAutofit xmlns:a="http://schemas.openxmlformats.org/drawingml/2006/main"/>
+          </a:bodyPr>
           <a:lstStyle/>
           <a:p>
             <a:fld id="{8DADB20D-508E-4C6D-A9E4-257D5607B0F6}" type="slidenum">
@@ -1717,7 +1793,9 @@
         </p:nvSpPr>
         <p:spPr/>
         <p:txBody>
-          <a:bodyPr/>
+          <a:bodyPr>
+            <a:normAutofit xmlns:a="http://schemas.openxmlformats.org/drawingml/2006/main"/>
+          </a:bodyPr>
           <a:lstStyle/>
           <a:p>
             <a:r>
@@ -1745,7 +1823,9 @@
           </a:xfrm>
         </p:spPr>
         <p:txBody>
-          <a:bodyPr/>
+          <a:bodyPr>
+            <a:normAutofit xmlns:a="http://schemas.openxmlformats.org/drawingml/2006/main"/>
+          </a:bodyPr>
           <a:lstStyle>
             <a:lvl1pPr>
               <a:defRPr sz="2800"/>
@@ -1830,7 +1910,9 @@
           </a:xfrm>
         </p:spPr>
         <p:txBody>
-          <a:bodyPr/>
+          <a:bodyPr>
+            <a:normAutofit xmlns:a="http://schemas.openxmlformats.org/drawingml/2006/main"/>
+          </a:bodyPr>
           <a:lstStyle>
             <a:lvl1pPr>
               <a:defRPr sz="2800"/>
@@ -1910,7 +1992,9 @@
         </p:nvSpPr>
         <p:spPr/>
         <p:txBody>
-          <a:bodyPr/>
+          <a:bodyPr>
+            <a:normAutofit xmlns:a="http://schemas.openxmlformats.org/drawingml/2006/main"/>
+          </a:bodyPr>
           <a:lstStyle/>
           <a:p>
             <a:fld id="{E6744CE3-0875-4B69-89C0-6F72D8139561}" type="datetimeFigureOut">
@@ -1933,7 +2017,9 @@
         </p:nvSpPr>
         <p:spPr/>
         <p:txBody>
-          <a:bodyPr/>
+          <a:bodyPr>
+            <a:normAutofit xmlns:a="http://schemas.openxmlformats.org/drawingml/2006/main"/>
+          </a:bodyPr>
           <a:lstStyle/>
           <a:p>
             <a:endParaRPr lang="en-GB"/>
@@ -1952,7 +2038,9 @@
         </p:nvSpPr>
         <p:spPr/>
         <p:txBody>
-          <a:bodyPr/>
+          <a:bodyPr>
+            <a:normAutofit xmlns:a="http://schemas.openxmlformats.org/drawingml/2006/main"/>
+          </a:bodyPr>
           <a:lstStyle/>
           <a:p>
             <a:fld id="{8DADB20D-508E-4C6D-A9E4-257D5607B0F6}" type="slidenum">
@@ -2019,7 +2107,7 @@
         </p:spPr>
         <p:txBody>
           <a:bodyPr vert="horz" lIns="91440" tIns="45720" rIns="91440" bIns="45720" rtlCol="0" anchor="ctr">
-            <a:normAutofit/>
+            <a:normAutofit xmlns:a="http://schemas.openxmlformats.org/drawingml/2006/main"/>
           </a:bodyPr>
           <a:lstStyle/>
           <a:p>
@@ -2052,7 +2140,7 @@
         </p:spPr>
         <p:txBody>
           <a:bodyPr vert="horz" lIns="91440" tIns="45720" rIns="91440" bIns="45720" rtlCol="0">
-            <a:normAutofit/>
+            <a:normAutofit xmlns:a="http://schemas.openxmlformats.org/drawingml/2006/main"/>
           </a:bodyPr>
           <a:lstStyle/>
           <a:p>
@@ -2113,7 +2201,9 @@
           </a:prstGeom>
         </p:spPr>
         <p:txBody>
-          <a:bodyPr vert="horz" lIns="91440" tIns="45720" rIns="91440" bIns="45720" rtlCol="0" anchor="ctr"/>
+          <a:bodyPr vert="horz" lIns="91440" tIns="45720" rIns="91440" bIns="45720" rtlCol="0" anchor="ctr">
+            <a:normAutofit xmlns:a="http://schemas.openxmlformats.org/drawingml/2006/main"/>
+          </a:bodyPr>
           <a:lstStyle>
             <a:lvl1pPr algn="l">
               <a:defRPr sz="1200">
@@ -2154,7 +2244,9 @@
           </a:prstGeom>
         </p:spPr>
         <p:txBody>
-          <a:bodyPr vert="horz" lIns="91440" tIns="45720" rIns="91440" bIns="45720" rtlCol="0" anchor="ctr"/>
+          <a:bodyPr vert="horz" lIns="91440" tIns="45720" rIns="91440" bIns="45720" rtlCol="0" anchor="ctr">
+            <a:normAutofit xmlns:a="http://schemas.openxmlformats.org/drawingml/2006/main"/>
+          </a:bodyPr>
           <a:lstStyle>
             <a:lvl1pPr algn="ctr">
               <a:defRPr sz="1200">
@@ -2191,7 +2283,9 @@
           </a:prstGeom>
         </p:spPr>
         <p:txBody>
-          <a:bodyPr vert="horz" lIns="91440" tIns="45720" rIns="91440" bIns="45720" rtlCol="0" anchor="ctr"/>
+          <a:bodyPr vert="horz" lIns="91440" tIns="45720" rIns="91440" bIns="45720" rtlCol="0" anchor="ctr">
+            <a:normAutofit xmlns:a="http://schemas.openxmlformats.org/drawingml/2006/main"/>
+          </a:bodyPr>
           <a:lstStyle>
             <a:lvl1pPr algn="r">
               <a:defRPr sz="1200">
@@ -2232,14 +2326,14 @@
   </p:sldLayoutIdLst>
   <p:txStyles>
     <p:titleStyle>
-      <a:lvl1pPr algn="ctr" defTabSz="914400" rtl="0" eaLnBrk="1" latinLnBrk="0" hangingPunct="1">
+      <a:lvl1pPr algn="l" defTabSz="914400" rtl="0" eaLnBrk="1" latinLnBrk="0" hangingPunct="1">
         <a:spcBef>
           <a:spcPct val="0"/>
         </a:spcBef>
         <a:buNone/>
-        <a:defRPr sz="4400" kern="1200">
-          <a:solidFill>
-            <a:schemeClr val="tx1"/>
+        <a:defRPr sz="2400" kern="1200">
+          <a:solidFill xmlns:a="http://schemas.openxmlformats.org/drawingml/2006/main">
+            <a:srgbClr val="12314E"/>
           </a:solidFill>
           <a:latin typeface="+mj-lt"/>
           <a:ea typeface="+mj-ea"/>
@@ -2254,7 +2348,7 @@
         </a:spcBef>
         <a:buFont typeface="Arial" panose="020B0604020202020204" pitchFamily="34" charset="0"/>
         <a:buChar char="•"/>
-        <a:defRPr sz="3200" kern="1200">
+        <a:defRPr sz="1400" kern="1200">
           <a:solidFill>
             <a:schemeClr val="tx1"/>
           </a:solidFill>
@@ -2500,28 +2594,28 @@
         <a:sysClr val="window" lastClr="FFFFFF"/>
       </a:lt1>
       <a:dk2>
-        <a:srgbClr val="1F497D"/>
+        <a:srgbClr val="12314E"/>
       </a:dk2>
       <a:lt2>
-        <a:srgbClr val="EEECE1"/>
+        <a:srgbClr val="EEF1F5"/>
       </a:lt2>
       <a:accent1>
-        <a:srgbClr val="4F81BD"/>
+        <a:srgbClr val="12314E"/>
       </a:accent1>
       <a:accent2>
-        <a:srgbClr val="C0504D"/>
+        <a:srgbClr val="C9A227"/>
       </a:accent2>
       <a:accent3>
-        <a:srgbClr val="9BBB59"/>
+        <a:srgbClr val="3E6E8E"/>
       </a:accent3>
       <a:accent4>
-        <a:srgbClr val="8064A2"/>
+        <a:srgbClr val="6E7C8C"/>
       </a:accent4>
       <a:accent5>
-        <a:srgbClr val="4BACC6"/>
+        <a:srgbClr val="A9B4C0"/>
       </a:accent5>
       <a:accent6>
-        <a:srgbClr val="F79646"/>
+        <a:srgbClr val="D8B04A"/>
       </a:accent6>
       <a:hlink>
         <a:srgbClr val="0000FF"/>

</xml_diff>